<commit_message>
Lesson sd-10-016: explain each data structure from the OpenJDK sources and MDN pages while keeping the source's names and examples, with the figure, metadata and deck
Co-Authored-By: Claude Sonnet 5.5 <noreply@anthropic.com>
Claude-Session: https://claude.ai/code/session_011dmt3ZFdN8sjiTfDnyUVN7
</commit_message>
<xml_diff>
--- a/system-design-101/vi/lessons/sd-10-016/slides/sd-10-016.pptx
+++ b/system-design-101/vi/lessons/sd-10-016/slides/sd-10-016.pptx
@@ -2342,7 +2342,7 @@
               <a:buNone/>
             </a:pPr>
             <a:r>
-              <a:rPr lang="en-US" sz="5100" dirty="0" spc="-4" kern="0">
+              <a:rPr lang="en-US" sz="5100" dirty="0" spc="1" kern="0">
                 <a:solidFill>
                   <a:srgbClr val="F3EEE3"/>
                 </a:solidFill>
@@ -2350,7 +2350,7 @@
                 <a:ea typeface="Bricolage Grotesque ExtraBold" pitchFamily="34" charset="-122"/>
                 <a:cs typeface="Bricolage Grotesque ExtraBold" pitchFamily="34" charset="-120"/>
               </a:rPr>
-              <a:t>4</a:t>
+              <a:t>8</a:t>
             </a:r>
             <a:endParaRPr lang="en-US" sz="5100" dirty="0"/>
           </a:p>
@@ -2384,7 +2384,7 @@
               <a:buNone/>
             </a:pPr>
             <a:r>
-              <a:rPr lang="en-US" sz="1650" dirty="0" spc="12" kern="0">
+              <a:rPr lang="en-US" sz="1650" dirty="0" spc="0" kern="0">
                 <a:solidFill>
                   <a:srgbClr val="9AA0B5"/>
                 </a:solidFill>
@@ -2392,7 +2392,18 @@
                 <a:ea typeface="Be Vietnam Pro" pitchFamily="34" charset="-122"/>
                 <a:cs typeface="Be Vietnam Pro" pitchFamily="34" charset="-120"/>
               </a:rPr>
-              <a:t>đối</a:t>
+              <a:t>có</a:t>
+            </a:r>
+            <a:r>
+              <a:rPr lang="en-US" sz="1650" dirty="0" spc="-6" kern="0">
+                <a:solidFill>
+                  <a:srgbClr val="9AA0B5"/>
+                </a:solidFill>
+                <a:latin typeface="Be Vietnam Pro" pitchFamily="34" charset="0"/>
+                <a:ea typeface="Be Vietnam Pro" pitchFamily="34" charset="-122"/>
+                <a:cs typeface="Be Vietnam Pro" pitchFamily="34" charset="-120"/>
+              </a:rPr>
+              <a:t> tài</a:t>
             </a:r>
             <a:r>
               <a:rPr lang="en-US" sz="1650" dirty="0" spc="0" kern="0">
@@ -2403,10 +2414,10 @@
                 <a:ea typeface="Be Vietnam Pro" pitchFamily="34" charset="-122"/>
                 <a:cs typeface="Be Vietnam Pro" pitchFamily="34" charset="-120"/>
               </a:rPr>
-              <a:t> chiếu</a:t>
-            </a:r>
-            <a:r>
-              <a:rPr lang="en-US" sz="1650" dirty="0" spc="-7" kern="0">
+              <a:t> liệu</a:t>
+            </a:r>
+            <a:r>
+              <a:rPr lang="en-US" sz="1650" dirty="0" spc="-9" kern="0">
                 <a:solidFill>
                   <a:srgbClr val="9AA0B5"/>
                 </a:solidFill>
@@ -2414,18 +2425,7 @@
                 <a:ea typeface="Be Vietnam Pro" pitchFamily="34" charset="-122"/>
                 <a:cs typeface="Be Vietnam Pro" pitchFamily="34" charset="-120"/>
               </a:rPr>
-              <a:t> với</a:t>
-            </a:r>
-            <a:r>
-              <a:rPr lang="en-US" sz="1650" dirty="0" spc="-12" kern="0">
-                <a:solidFill>
-                  <a:srgbClr val="9AA0B5"/>
-                </a:solidFill>
-                <a:latin typeface="Be Vietnam Pro" pitchFamily="34" charset="0"/>
-                <a:ea typeface="Be Vietnam Pro" pitchFamily="34" charset="-122"/>
-                <a:cs typeface="Be Vietnam Pro" pitchFamily="34" charset="-120"/>
-              </a:rPr>
-              <a:t> Java</a:t>
+              <a:t> gốc</a:t>
             </a:r>
             <a:endParaRPr lang="en-US" sz="1650" dirty="0"/>
           </a:p>
@@ -4437,6 +4437,17 @@
               <a:t> chiếu</a:t>
             </a:r>
             <a:r>
+              <a:rPr lang="en-US" sz="2400" dirty="0" spc="-8" kern="0">
+                <a:solidFill>
+                  <a:srgbClr val="14161C"/>
+                </a:solidFill>
+                <a:latin typeface="Be Vietnam Pro" pitchFamily="34" charset="0"/>
+                <a:ea typeface="Be Vietnam Pro" pitchFamily="34" charset="-122"/>
+                <a:cs typeface="Be Vietnam Pro" pitchFamily="34" charset="-120"/>
+              </a:rPr>
+              <a:t> tám</a:t>
+            </a:r>
+            <a:r>
               <a:rPr lang="en-US" sz="2400" dirty="0" spc="-1" kern="0">
                 <a:solidFill>
                   <a:srgbClr val="14161C"/>
@@ -4445,7 +4456,7 @@
                 <a:ea typeface="Be Vietnam Pro" pitchFamily="34" charset="-122"/>
                 <a:cs typeface="Be Vietnam Pro" pitchFamily="34" charset="-120"/>
               </a:rPr>
-              <a:t> bốn cấu</a:t>
+              <a:t> cấu</a:t>
             </a:r>
             <a:r>
               <a:rPr lang="en-US" sz="2400" dirty="0" spc="2" kern="0">
@@ -4470,15 +4481,37 @@
               <a:t> với</a:t>
             </a:r>
             <a:r>
-              <a:rPr lang="en-US" sz="2400" dirty="0" spc="-18" kern="0">
-                <a:solidFill>
-                  <a:srgbClr val="14161C"/>
-                </a:solidFill>
-                <a:latin typeface="Be Vietnam Pro" pitchFamily="34" charset="0"/>
-                <a:ea typeface="Be Vietnam Pro" pitchFamily="34" charset="-122"/>
-                <a:cs typeface="Be Vietnam Pro" pitchFamily="34" charset="-120"/>
-              </a:rPr>
-              <a:t> Java</a:t>
+              <a:rPr lang="en-US" sz="2400" dirty="0" spc="-11" kern="0">
+                <a:solidFill>
+                  <a:srgbClr val="14161C"/>
+                </a:solidFill>
+                <a:latin typeface="Be Vietnam Pro" pitchFamily="34" charset="0"/>
+                <a:ea typeface="Be Vietnam Pro" pitchFamily="34" charset="-122"/>
+                <a:cs typeface="Be Vietnam Pro" pitchFamily="34" charset="-120"/>
+              </a:rPr>
+              <a:t> tài</a:t>
+            </a:r>
+            <a:r>
+              <a:rPr lang="en-US" sz="2400" dirty="0" spc="-1" kern="0">
+                <a:solidFill>
+                  <a:srgbClr val="14161C"/>
+                </a:solidFill>
+                <a:latin typeface="Be Vietnam Pro" pitchFamily="34" charset="0"/>
+                <a:ea typeface="Be Vietnam Pro" pitchFamily="34" charset="-122"/>
+                <a:cs typeface="Be Vietnam Pro" pitchFamily="34" charset="-120"/>
+              </a:rPr>
+              <a:t> liệu</a:t>
+            </a:r>
+            <a:r>
+              <a:rPr lang="en-US" sz="2400" dirty="0" spc="-14" kern="0">
+                <a:solidFill>
+                  <a:srgbClr val="14161C"/>
+                </a:solidFill>
+                <a:latin typeface="Be Vietnam Pro" pitchFamily="34" charset="0"/>
+                <a:ea typeface="Be Vietnam Pro" pitchFamily="34" charset="-122"/>
+                <a:cs typeface="Be Vietnam Pro" pitchFamily="34" charset="-120"/>
+              </a:rPr>
+              <a:t> gốc</a:t>
             </a:r>
             <a:endParaRPr lang="en-US" sz="2400" dirty="0"/>
           </a:p>
@@ -20258,7 +20291,7 @@
               <a:buChar char="•"/>
             </a:pPr>
             <a:r>
-              <a:rPr lang="en-US" sz="2250" dirty="0" spc="-4" kern="0">
+              <a:rPr lang="en-US" sz="2250" dirty="0" spc="-1" kern="0">
                 <a:solidFill>
                   <a:srgbClr val="F3EEE3"/>
                 </a:solidFill>
@@ -20266,7 +20299,7 @@
                 <a:ea typeface="Be Vietnam Pro" pitchFamily="34" charset="-122"/>
                 <a:cs typeface="Be Vietnam Pro" pitchFamily="34" charset="-120"/>
               </a:rPr>
-              <a:t>ByteByteGo:</a:t>
+              <a:t>OpenJDK:</a:t>
             </a:r>
             <a:r>
               <a:rPr lang="en-US" sz="2250" dirty="0" spc="-3" kern="0">
@@ -20277,10 +20310,10 @@
                 <a:ea typeface="Be Vietnam Pro" pitchFamily="34" charset="-122"/>
                 <a:cs typeface="Be Vietnam Pro" pitchFamily="34" charset="-120"/>
               </a:rPr>
-              <a:t> bài</a:t>
-            </a:r>
-            <a:r>
-              <a:rPr lang="en-US" sz="2250" dirty="0" spc="1" kern="0">
+              <a:t> List,</a:t>
+            </a:r>
+            <a:r>
+              <a:rPr lang="en-US" sz="2250" dirty="0" spc="-2" kern="0">
                 <a:solidFill>
                   <a:srgbClr val="F3EEE3"/>
                 </a:solidFill>
@@ -20288,10 +20321,10 @@
                 <a:ea typeface="Be Vietnam Pro" pitchFamily="34" charset="-122"/>
                 <a:cs typeface="Be Vietnam Pro" pitchFamily="34" charset="-120"/>
               </a:rPr>
-              <a:t> nguồn</a:t>
-            </a:r>
-            <a:r>
-              <a:rPr lang="en-US" sz="2250" dirty="0" spc="-12" kern="0">
+              <a:t> Deque,</a:t>
+            </a:r>
+            <a:r>
+              <a:rPr lang="en-US" sz="2250" dirty="0" spc="-1" kern="0">
                 <a:solidFill>
                   <a:srgbClr val="F3EEE3"/>
                 </a:solidFill>
@@ -20299,10 +20332,10 @@
                 <a:ea typeface="Be Vietnam Pro" pitchFamily="34" charset="-122"/>
                 <a:cs typeface="Be Vietnam Pro" pitchFamily="34" charset="-120"/>
               </a:rPr>
-              <a:t> tại</a:t>
-            </a:r>
-            <a:r>
-              <a:rPr lang="en-US" sz="2250" dirty="0" spc="-1" kern="0">
+              <a:t> Queue,</a:t>
+            </a:r>
+            <a:r>
+              <a:rPr lang="en-US" sz="2250" dirty="0" spc="2" kern="0">
                 <a:solidFill>
                   <a:srgbClr val="F3EEE3"/>
                 </a:solidFill>
@@ -20310,10 +20343,10 @@
                 <a:ea typeface="Be Vietnam Pro" pitchFamily="34" charset="-122"/>
                 <a:cs typeface="Be Vietnam Pro" pitchFamily="34" charset="-120"/>
               </a:rPr>
-              <a:t> commit</a:t>
-            </a:r>
-            <a:r>
-              <a:rPr lang="en-US" sz="2250" dirty="0" spc="4" kern="0">
+              <a:t> PriorityQueue,</a:t>
+            </a:r>
+            <a:r>
+              <a:rPr lang="en-US" sz="2250" dirty="0" spc="-3" kern="0">
                 <a:solidFill>
                   <a:srgbClr val="F3EEE3"/>
                 </a:solidFill>
@@ -20321,18 +20354,7 @@
                 <a:ea typeface="Be Vietnam Pro" pitchFamily="34" charset="-122"/>
                 <a:cs typeface="Be Vietnam Pro" pitchFamily="34" charset="-120"/>
               </a:rPr>
-              <a:t> cố</a:t>
-            </a:r>
-            <a:r>
-              <a:rPr lang="en-US" sz="2250" dirty="0" spc="19" kern="0">
-                <a:solidFill>
-                  <a:srgbClr val="F3EEE3"/>
-                </a:solidFill>
-                <a:latin typeface="Be Vietnam Pro" pitchFamily="34" charset="0"/>
-                <a:ea typeface="Be Vietnam Pro" pitchFamily="34" charset="-122"/>
-                <a:cs typeface="Be Vietnam Pro" pitchFamily="34" charset="-120"/>
-              </a:rPr>
-              <a:t> định</a:t>
+              <a:t> HashSet</a:t>
             </a:r>
             <a:endParaRPr lang="en-US" sz="2250" dirty="0"/>
           </a:p>
@@ -20354,7 +20376,18 @@
                 <a:ea typeface="Be Vietnam Pro" pitchFamily="34" charset="-122"/>
                 <a:cs typeface="Be Vietnam Pro" pitchFamily="34" charset="-120"/>
               </a:rPr>
-              <a:t>OpenJDK:</a:t>
+              <a:t>MDN:</a:t>
+            </a:r>
+            <a:r>
+              <a:rPr lang="en-US" sz="2250" dirty="0" spc="-19" kern="0">
+                <a:solidFill>
+                  <a:srgbClr val="F3EEE3"/>
+                </a:solidFill>
+                <a:latin typeface="Be Vietnam Pro" pitchFamily="34" charset="0"/>
+                <a:ea typeface="Be Vietnam Pro" pitchFamily="34" charset="-122"/>
+                <a:cs typeface="Be Vietnam Pro" pitchFamily="34" charset="-120"/>
+              </a:rPr>
+              <a:t> Array,</a:t>
             </a:r>
             <a:r>
               <a:rPr lang="en-US" sz="2250" dirty="0" spc="-2" kern="0">
@@ -20365,10 +20398,10 @@
                 <a:ea typeface="Be Vietnam Pro" pitchFamily="34" charset="-122"/>
                 <a:cs typeface="Be Vietnam Pro" pitchFamily="34" charset="-120"/>
               </a:rPr>
-              <a:t> Deque,</a:t>
-            </a:r>
-            <a:r>
-              <a:rPr lang="en-US" sz="2250" dirty="0" spc="-1" kern="0">
+              <a:t> DOM, GPU,</a:t>
+            </a:r>
+            <a:r>
+              <a:rPr lang="en-US" sz="2250" dirty="0" spc="-16" kern="0">
                 <a:solidFill>
                   <a:srgbClr val="F3EEE3"/>
                 </a:solidFill>
@@ -20376,29 +20409,7 @@
                 <a:ea typeface="Be Vietnam Pro" pitchFamily="34" charset="-122"/>
                 <a:cs typeface="Be Vietnam Pro" pitchFamily="34" charset="-120"/>
               </a:rPr>
-              <a:t> Queue,</a:t>
-            </a:r>
-            <a:r>
-              <a:rPr lang="en-US" sz="2250" dirty="0" spc="2" kern="0">
-                <a:solidFill>
-                  <a:srgbClr val="F3EEE3"/>
-                </a:solidFill>
-                <a:latin typeface="Be Vietnam Pro" pitchFamily="34" charset="0"/>
-                <a:ea typeface="Be Vietnam Pro" pitchFamily="34" charset="-122"/>
-                <a:cs typeface="Be Vietnam Pro" pitchFamily="34" charset="-120"/>
-              </a:rPr>
-              <a:t> PriorityQueue,</a:t>
-            </a:r>
-            <a:r>
-              <a:rPr lang="en-US" sz="2250" dirty="0" spc="-3" kern="0">
-                <a:solidFill>
-                  <a:srgbClr val="F3EEE3"/>
-                </a:solidFill>
-                <a:latin typeface="Be Vietnam Pro" pitchFamily="34" charset="0"/>
-                <a:ea typeface="Be Vietnam Pro" pitchFamily="34" charset="-122"/>
-                <a:cs typeface="Be Vietnam Pro" pitchFamily="34" charset="-120"/>
-              </a:rPr>
-              <a:t> HashSet</a:t>
+              <a:t> WebGLBuffer</a:t>
             </a:r>
             <a:endParaRPr lang="en-US" sz="2250" dirty="0"/>
           </a:p>
@@ -20429,6 +20440,17 @@
               <a:buNone/>
             </a:pPr>
             <a:r>
+              <a:rPr lang="en-US" sz="2100" dirty="0" spc="-6" kern="0">
+                <a:solidFill>
+                  <a:srgbClr val="C4C8D6"/>
+                </a:solidFill>
+                <a:latin typeface="Be Vietnam Pro" pitchFamily="34" charset="0"/>
+                <a:ea typeface="Be Vietnam Pro" pitchFamily="34" charset="-122"/>
+                <a:cs typeface="Be Vietnam Pro" pitchFamily="34" charset="-120"/>
+              </a:rPr>
+              <a:t>ByteByteGo</a:t>
+            </a:r>
+            <a:r>
               <a:rPr lang="en-US" sz="2100" dirty="0" spc="1" kern="0">
                 <a:solidFill>
                   <a:srgbClr val="C4C8D6"/>
@@ -20437,7 +20459,73 @@
                 <a:ea typeface="Be Vietnam Pro" pitchFamily="34" charset="-122"/>
                 <a:cs typeface="Be Vietnam Pro" pitchFamily="34" charset="-120"/>
               </a:rPr>
-              <a:t>Đã</a:t>
+              <a:t> chỉ</a:t>
+            </a:r>
+            <a:r>
+              <a:rPr lang="en-US" sz="2100" dirty="0" spc="-2" kern="0">
+                <a:solidFill>
+                  <a:srgbClr val="C4C8D6"/>
+                </a:solidFill>
+                <a:latin typeface="Be Vietnam Pro" pitchFamily="34" charset="0"/>
+                <a:ea typeface="Be Vietnam Pro" pitchFamily="34" charset="-122"/>
+                <a:cs typeface="Be Vietnam Pro" pitchFamily="34" charset="-120"/>
+              </a:rPr>
+              <a:t> cho</a:t>
+            </a:r>
+            <a:r>
+              <a:rPr lang="en-US" sz="2100" dirty="0" spc="-10" kern="0">
+                <a:solidFill>
+                  <a:srgbClr val="C4C8D6"/>
+                </a:solidFill>
+                <a:latin typeface="Be Vietnam Pro" pitchFamily="34" charset="0"/>
+                <a:ea typeface="Be Vietnam Pro" pitchFamily="34" charset="-122"/>
+                <a:cs typeface="Be Vietnam Pro" pitchFamily="34" charset="-120"/>
+              </a:rPr>
+              <a:t> tên</a:t>
+            </a:r>
+            <a:r>
+              <a:rPr lang="en-US" sz="2100" dirty="0" spc="-18" kern="0">
+                <a:solidFill>
+                  <a:srgbClr val="C4C8D6"/>
+                </a:solidFill>
+                <a:latin typeface="Be Vietnam Pro" pitchFamily="34" charset="0"/>
+                <a:ea typeface="Be Vietnam Pro" pitchFamily="34" charset="-122"/>
+                <a:cs typeface="Be Vietnam Pro" pitchFamily="34" charset="-120"/>
+              </a:rPr>
+              <a:t> và</a:t>
+            </a:r>
+            <a:r>
+              <a:rPr lang="en-US" sz="2100" dirty="0" spc="-1" kern="0">
+                <a:solidFill>
+                  <a:srgbClr val="C4C8D6"/>
+                </a:solidFill>
+                <a:latin typeface="Be Vietnam Pro" pitchFamily="34" charset="0"/>
+                <a:ea typeface="Be Vietnam Pro" pitchFamily="34" charset="-122"/>
+                <a:cs typeface="Be Vietnam Pro" pitchFamily="34" charset="-120"/>
+              </a:rPr>
+              <a:t> ví</a:t>
+            </a:r>
+            <a:r>
+              <a:rPr lang="en-US" sz="2100" dirty="0" spc="-2" kern="0">
+                <a:solidFill>
+                  <a:srgbClr val="C4C8D6"/>
+                </a:solidFill>
+                <a:latin typeface="Be Vietnam Pro" pitchFamily="34" charset="0"/>
+                <a:ea typeface="Be Vietnam Pro" pitchFamily="34" charset="-122"/>
+                <a:cs typeface="Be Vietnam Pro" pitchFamily="34" charset="-120"/>
+              </a:rPr>
+              <a:t> dụ.</a:t>
+            </a:r>
+            <a:r>
+              <a:rPr lang="en-US" sz="2100" dirty="0" spc="-1" kern="0">
+                <a:solidFill>
+                  <a:srgbClr val="C4C8D6"/>
+                </a:solidFill>
+                <a:latin typeface="Be Vietnam Pro" pitchFamily="34" charset="0"/>
+                <a:ea typeface="Be Vietnam Pro" pitchFamily="34" charset="-122"/>
+                <a:cs typeface="Be Vietnam Pro" pitchFamily="34" charset="-120"/>
+              </a:rPr>
+              <a:t> Đã</a:t>
             </a:r>
             <a:r>
               <a:rPr lang="en-US" sz="2100" dirty="0" spc="6" kern="0">
@@ -20451,6 +20539,72 @@
               <a:t> đọc</a:t>
             </a:r>
             <a:r>
+              <a:rPr lang="en-US" sz="2100" dirty="0" spc="-16" kern="0">
+                <a:solidFill>
+                  <a:srgbClr val="C4C8D6"/>
+                </a:solidFill>
+                <a:latin typeface="Be Vietnam Pro" pitchFamily="34" charset="0"/>
+                <a:ea typeface="Be Vietnam Pro" pitchFamily="34" charset="-122"/>
+                <a:cs typeface="Be Vietnam Pro" pitchFamily="34" charset="-120"/>
+              </a:rPr>
+              <a:t> ngày</a:t>
+            </a:r>
+            <a:r>
+              <a:rPr lang="en-US" sz="2100" dirty="0" spc="0" kern="0">
+                <a:solidFill>
+                  <a:srgbClr val="C4C8D6"/>
+                </a:solidFill>
+                <a:latin typeface="Be Vietnam Pro" pitchFamily="34" charset="0"/>
+                <a:ea typeface="Be Vietnam Pro" pitchFamily="34" charset="-122"/>
+                <a:cs typeface="Be Vietnam Pro" pitchFamily="34" charset="-120"/>
+              </a:rPr>
+              <a:t> 2026-10-19.</a:t>
+            </a:r>
+            <a:r>
+              <a:rPr lang="en-US" sz="2100" dirty="0" spc="-10" kern="0">
+                <a:solidFill>
+                  <a:srgbClr val="C4C8D6"/>
+                </a:solidFill>
+                <a:latin typeface="Be Vietnam Pro" pitchFamily="34" charset="0"/>
+                <a:ea typeface="Be Vietnam Pro" pitchFamily="34" charset="-122"/>
+                <a:cs typeface="Be Vietnam Pro" pitchFamily="34" charset="-120"/>
+              </a:rPr>
+              <a:t> Cây</a:t>
+            </a:r>
+            <a:r>
+              <a:rPr lang="en-US" sz="2100" dirty="0" spc="-2" kern="0">
+                <a:solidFill>
+                  <a:srgbClr val="C4C8D6"/>
+                </a:solidFill>
+                <a:latin typeface="Be Vietnam Pro" pitchFamily="34" charset="0"/>
+                <a:ea typeface="Be Vietnam Pro" pitchFamily="34" charset="-122"/>
+                <a:cs typeface="Be Vietnam Pro" pitchFamily="34" charset="-120"/>
+              </a:rPr>
+              <a:t> hậu</a:t>
+            </a:r>
+            <a:r>
+              <a:rPr lang="en-US" sz="2100" dirty="0" spc="-13" kern="0">
+                <a:solidFill>
+                  <a:srgbClr val="C4C8D6"/>
+                </a:solidFill>
+                <a:latin typeface="Be Vietnam Pro" pitchFamily="34" charset="0"/>
+                <a:ea typeface="Be Vietnam Pro" pitchFamily="34" charset="-122"/>
+                <a:cs typeface="Be Vietnam Pro" pitchFamily="34" charset="-120"/>
+              </a:rPr>
+              <a:t> tố,</a:t>
+            </a:r>
+            <a:r>
+              <a:rPr lang="en-US" sz="2100" dirty="0" spc="11" kern="0">
+                <a:solidFill>
+                  <a:srgbClr val="C4C8D6"/>
+                </a:solidFill>
+                <a:latin typeface="Be Vietnam Pro" pitchFamily="34" charset="0"/>
+                <a:ea typeface="Be Vietnam Pro" pitchFamily="34" charset="-122"/>
+                <a:cs typeface="Be Vietnam Pro" pitchFamily="34" charset="-120"/>
+              </a:rPr>
+              <a:t> đồ</a:t>
+            </a:r>
+            <a:r>
               <a:rPr lang="en-US" sz="2100" dirty="0" spc="-1" kern="0">
                 <a:solidFill>
                   <a:srgbClr val="C4C8D6"/>
@@ -20459,7 +20613,7 @@
                 <a:ea typeface="Be Vietnam Pro" pitchFamily="34" charset="-122"/>
                 <a:cs typeface="Be Vietnam Pro" pitchFamily="34" charset="-120"/>
               </a:rPr>
-              <a:t> nguồn</a:t>
+              <a:t> thị,</a:t>
             </a:r>
             <a:r>
               <a:rPr lang="en-US" sz="2100" dirty="0" spc="-15" kern="0">
@@ -20470,10 +20624,10 @@
                 <a:ea typeface="Be Vietnam Pro" pitchFamily="34" charset="-122"/>
                 <a:cs typeface="Be Vietnam Pro" pitchFamily="34" charset="-120"/>
               </a:rPr>
-              <a:t> ngày</a:t>
-            </a:r>
-            <a:r>
-              <a:rPr lang="en-US" sz="2100" dirty="0" spc="-1" kern="0">
+              <a:t> R-tree</a:t>
+            </a:r>
+            <a:r>
+              <a:rPr lang="en-US" sz="2100" dirty="0" spc="4" kern="0">
                 <a:solidFill>
                   <a:srgbClr val="C4C8D6"/>
                 </a:solidFill>
@@ -20481,10 +20635,10 @@
                 <a:ea typeface="Be Vietnam Pro" pitchFamily="34" charset="-122"/>
                 <a:cs typeface="Be Vietnam Pro" pitchFamily="34" charset="-120"/>
               </a:rPr>
-              <a:t> 2026-10-18.</a:t>
-            </a:r>
-            <a:r>
-              <a:rPr lang="en-US" sz="2100" dirty="0" spc="0" kern="0">
+              <a:t> chưa</a:t>
+            </a:r>
+            <a:r>
+              <a:rPr lang="en-US" sz="2100" dirty="0" spc="10" kern="0">
                 <a:solidFill>
                   <a:srgbClr val="C4C8D6"/>
                 </a:solidFill>
@@ -20492,7 +20646,7 @@
                 <a:ea typeface="Be Vietnam Pro" pitchFamily="34" charset="-122"/>
                 <a:cs typeface="Be Vietnam Pro" pitchFamily="34" charset="-120"/>
               </a:rPr>
-              <a:t> Hình</a:t>
+              <a:t> đối</a:t>
             </a:r>
             <a:r>
               <a:rPr lang="en-US" sz="2100" dirty="0" spc="1" kern="0">
@@ -20503,62 +20657,7 @@
                 <a:ea typeface="Be Vietnam Pro" pitchFamily="34" charset="-122"/>
                 <a:cs typeface="Be Vietnam Pro" pitchFamily="34" charset="-120"/>
               </a:rPr>
-              <a:t> minh</a:t>
-            </a:r>
-            <a:r>
-              <a:rPr lang="en-US" sz="2100" dirty="0" spc="-6" kern="0">
-                <a:solidFill>
-                  <a:srgbClr val="C4C8D6"/>
-                </a:solidFill>
-                <a:latin typeface="Be Vietnam Pro" pitchFamily="34" charset="0"/>
-                <a:ea typeface="Be Vietnam Pro" pitchFamily="34" charset="-122"/>
-                <a:cs typeface="Be Vietnam Pro" pitchFamily="34" charset="-120"/>
-              </a:rPr>
-              <a:t> họa</a:t>
-            </a:r>
-            <a:r>
-              <a:rPr lang="en-US" sz="2100" dirty="0" spc="-3" kern="0">
-                <a:solidFill>
-                  <a:srgbClr val="C4C8D6"/>
-                </a:solidFill>
-                <a:latin typeface="Be Vietnam Pro" pitchFamily="34" charset="0"/>
-                <a:ea typeface="Be Vietnam Pro" pitchFamily="34" charset="-122"/>
-                <a:cs typeface="Be Vietnam Pro" pitchFamily="34" charset="-120"/>
-              </a:rPr>
-              <a:t> là</a:t>
-            </a:r>
-            <a:r>
-              <a:rPr lang="en-US" sz="2100" dirty="0" spc="-4" kern="0">
-                <a:solidFill>
-                  <a:srgbClr val="C4C8D6"/>
-                </a:solidFill>
-                <a:latin typeface="Be Vietnam Pro" pitchFamily="34" charset="0"/>
-                <a:ea typeface="Be Vietnam Pro" pitchFamily="34" charset="-122"/>
-                <a:cs typeface="Be Vietnam Pro" pitchFamily="34" charset="-120"/>
-              </a:rPr>
-              <a:t> thiết</a:t>
-            </a:r>
-            <a:r>
-              <a:rPr lang="en-US" sz="2100" dirty="0" spc="-30" kern="0">
-                <a:solidFill>
-                  <a:srgbClr val="C4C8D6"/>
-                </a:solidFill>
-                <a:latin typeface="Be Vietnam Pro" pitchFamily="34" charset="0"/>
-                <a:ea typeface="Be Vietnam Pro" pitchFamily="34" charset="-122"/>
-                <a:cs typeface="Be Vietnam Pro" pitchFamily="34" charset="-120"/>
-              </a:rPr>
-              <a:t> kế</a:t>
-            </a:r>
-            <a:r>
-              <a:rPr lang="en-US" sz="2100" dirty="0" spc="-1" kern="0">
-                <a:solidFill>
-                  <a:srgbClr val="C4C8D6"/>
-                </a:solidFill>
-                <a:latin typeface="Be Vietnam Pro" pitchFamily="34" charset="0"/>
-                <a:ea typeface="Be Vietnam Pro" pitchFamily="34" charset="-122"/>
-                <a:cs typeface="Be Vietnam Pro" pitchFamily="34" charset="-120"/>
-              </a:rPr>
-              <a:t> mới.</a:t>
+              <a:t> chiếu.</a:t>
             </a:r>
             <a:endParaRPr lang="en-US" sz="2100" dirty="0"/>
           </a:p>

</xml_diff>

<commit_message>
Lesson sd-10-016: show all five Java structures, List included, on the deck's Java library slide
Co-Authored-By: Claude Sonnet 5.5 <noreply@anthropic.com>
Claude-Session: https://claude.ai/code/session_011dmt3ZFdN8sjiTfDnyUVN7
</commit_message>
<xml_diff>
--- a/system-design-101/vi/lessons/sd-10-016/slides/sd-10-016.pptx
+++ b/system-design-101/vi/lessons/sd-10-016/slides/sd-10-016.pptx
@@ -12403,15 +12403,15 @@
               <a:buNone/>
             </a:pPr>
             <a:r>
-              <a:rPr lang="en-US" sz="3000" b="1" dirty="0" spc="-8" kern="0">
-                <a:solidFill>
-                  <a:srgbClr val="14161C"/>
-                </a:solidFill>
-                <a:latin typeface="Be Vietnam Pro" pitchFamily="34" charset="0"/>
-                <a:ea typeface="Be Vietnam Pro" pitchFamily="34" charset="-122"/>
-                <a:cs typeface="Be Vietnam Pro" pitchFamily="34" charset="-120"/>
-              </a:rPr>
-              <a:t>Bốn</a:t>
+              <a:rPr lang="en-US" sz="3000" b="1" dirty="0" spc="-3" kern="0">
+                <a:solidFill>
+                  <a:srgbClr val="14161C"/>
+                </a:solidFill>
+                <a:latin typeface="Be Vietnam Pro" pitchFamily="34" charset="0"/>
+                <a:ea typeface="Be Vietnam Pro" pitchFamily="34" charset="-122"/>
+                <a:cs typeface="Be Vietnam Pro" pitchFamily="34" charset="-120"/>
+              </a:rPr>
+              <a:t>Năm</a:t>
             </a:r>
             <a:r>
               <a:rPr lang="en-US" sz="3000" b="1" dirty="0" spc="1" kern="0">
@@ -12422,21 +12422,10 @@
                 <a:ea typeface="Be Vietnam Pro" pitchFamily="34" charset="-122"/>
                 <a:cs typeface="Be Vietnam Pro" pitchFamily="34" charset="-120"/>
               </a:rPr>
-              <a:t> cấu</a:t>
-            </a:r>
-            <a:r>
-              <a:rPr lang="en-US" sz="3000" b="1" dirty="0" spc="2" kern="0">
-                <a:solidFill>
-                  <a:srgbClr val="14161C"/>
-                </a:solidFill>
-                <a:latin typeface="Be Vietnam Pro" pitchFamily="34" charset="0"/>
-                <a:ea typeface="Be Vietnam Pro" pitchFamily="34" charset="-122"/>
-                <a:cs typeface="Be Vietnam Pro" pitchFamily="34" charset="-120"/>
-              </a:rPr>
-              <a:t> trúc</a:t>
-            </a:r>
-            <a:r>
-              <a:rPr lang="en-US" sz="3000" b="1" dirty="0" spc="-6" kern="0">
+              <a:t> cấu trúc</a:t>
+            </a:r>
+            <a:r>
+              <a:rPr lang="en-US" sz="3000" b="1" dirty="0" spc="-5" kern="0">
                 <a:solidFill>
                   <a:srgbClr val="14161C"/>
                 </a:solidFill>
@@ -13125,7 +13114,7 @@
         </p:nvSpPr>
         <p:spPr>
           <a:xfrm>
-            <a:off x="12687300" y="2362200"/>
+            <a:off x="12687300" y="3581400"/>
             <a:ext cx="628650" cy="0"/>
           </a:xfrm>
           <a:prstGeom prst="line">
@@ -13150,12 +13139,12 @@
         </p:nvSpPr>
         <p:spPr>
           <a:xfrm>
-            <a:off x="13411200" y="1600200"/>
-            <a:ext cx="3657600" cy="1524000"/>
+            <a:off x="13411200" y="2971800"/>
+            <a:ext cx="3657600" cy="1219200"/>
           </a:xfrm>
           <a:prstGeom prst="roundRect">
             <a:avLst>
-              <a:gd name="adj" fmla="val 15000"/>
+              <a:gd name="adj" fmla="val 18750"/>
             </a:avLst>
           </a:prstGeom>
           <a:solidFill>
@@ -13177,7 +13166,7 @@
         </p:nvSpPr>
         <p:spPr>
           <a:xfrm>
-            <a:off x="13639800" y="1809750"/>
+            <a:off x="13639800" y="3067050"/>
             <a:ext cx="3238500" cy="495300"/>
           </a:xfrm>
           <a:prstGeom prst="rect">
@@ -13216,7 +13205,7 @@
         </p:nvSpPr>
         <p:spPr>
           <a:xfrm>
-            <a:off x="13639800" y="2362200"/>
+            <a:off x="13639800" y="3562350"/>
             <a:ext cx="3238500" cy="685800"/>
           </a:xfrm>
           <a:prstGeom prst="rect">
@@ -13302,7 +13291,7 @@
         </p:nvSpPr>
         <p:spPr>
           <a:xfrm>
-            <a:off x="12687300" y="4095750"/>
+            <a:off x="12687300" y="4953000"/>
             <a:ext cx="628650" cy="0"/>
           </a:xfrm>
           <a:prstGeom prst="line">
@@ -13327,12 +13316,12 @@
         </p:nvSpPr>
         <p:spPr>
           <a:xfrm>
-            <a:off x="13411200" y="3333750"/>
-            <a:ext cx="3657600" cy="1524000"/>
+            <a:off x="13411200" y="4343400"/>
+            <a:ext cx="3657600" cy="1219200"/>
           </a:xfrm>
           <a:prstGeom prst="roundRect">
             <a:avLst>
-              <a:gd name="adj" fmla="val 15000"/>
+              <a:gd name="adj" fmla="val 18750"/>
             </a:avLst>
           </a:prstGeom>
           <a:solidFill>
@@ -13354,7 +13343,7 @@
         </p:nvSpPr>
         <p:spPr>
           <a:xfrm>
-            <a:off x="13639800" y="3543300"/>
+            <a:off x="13639800" y="4438650"/>
             <a:ext cx="3238500" cy="495300"/>
           </a:xfrm>
           <a:prstGeom prst="rect">
@@ -13393,7 +13382,7 @@
         </p:nvSpPr>
         <p:spPr>
           <a:xfrm>
-            <a:off x="13639800" y="4095750"/>
+            <a:off x="13639800" y="4933950"/>
             <a:ext cx="3238500" cy="685800"/>
           </a:xfrm>
           <a:prstGeom prst="rect">
@@ -13512,7 +13501,7 @@
         </p:nvSpPr>
         <p:spPr>
           <a:xfrm>
-            <a:off x="12687300" y="5829300"/>
+            <a:off x="12687300" y="6324600"/>
             <a:ext cx="628650" cy="0"/>
           </a:xfrm>
           <a:prstGeom prst="line">
@@ -13537,12 +13526,12 @@
         </p:nvSpPr>
         <p:spPr>
           <a:xfrm>
-            <a:off x="13411200" y="5067300"/>
-            <a:ext cx="3657600" cy="1524000"/>
+            <a:off x="13411200" y="5715000"/>
+            <a:ext cx="3657600" cy="1219200"/>
           </a:xfrm>
           <a:prstGeom prst="roundRect">
             <a:avLst>
-              <a:gd name="adj" fmla="val 15000"/>
+              <a:gd name="adj" fmla="val 18750"/>
             </a:avLst>
           </a:prstGeom>
           <a:solidFill>
@@ -13564,7 +13553,7 @@
         </p:nvSpPr>
         <p:spPr>
           <a:xfrm>
-            <a:off x="13639800" y="5276850"/>
+            <a:off x="13639800" y="5810250"/>
             <a:ext cx="3238500" cy="495300"/>
           </a:xfrm>
           <a:prstGeom prst="rect">
@@ -13597,13 +13586,38 @@
       </p:sp>
       <p:sp>
         <p:nvSpPr>
-          <p:cNvPr id="23" name="Text 21"/>
-          <p:cNvSpPr/>
-          <p:nvPr/>
-        </p:nvSpPr>
-        <p:spPr>
-          <a:xfrm>
-            <a:off x="13639800" y="5829300"/>
+          <p:cNvPr id="23" name="Connector line-1792420733825-298648923"/>
+          <p:cNvSpPr/>
+          <p:nvPr/>
+        </p:nvSpPr>
+        <p:spPr>
+          <a:xfrm>
+            <a:off x="12687300" y="2209800"/>
+            <a:ext cx="628650" cy="0"/>
+          </a:xfrm>
+          <a:prstGeom prst="line">
+            <a:avLst/>
+          </a:prstGeom>
+          <a:noFill/>
+          <a:ln w="47625">
+            <a:solidFill>
+              <a:srgbClr val="1F3FD1"/>
+            </a:solidFill>
+            <a:prstDash val="solid"/>
+            <a:headEnd type="none"/>
+            <a:tailEnd type="triangle"/>
+          </a:ln>
+        </p:spPr>
+      </p:sp>
+      <p:sp>
+        <p:nvSpPr>
+          <p:cNvPr id="24" name="Text 22"/>
+          <p:cNvSpPr/>
+          <p:nvPr/>
+        </p:nvSpPr>
+        <p:spPr>
+          <a:xfrm>
+            <a:off x="13639800" y="6305550"/>
             <a:ext cx="3238500" cy="685800"/>
           </a:xfrm>
           <a:prstGeom prst="rect">
@@ -13727,13 +13741,40 @@
       </p:sp>
       <p:sp>
         <p:nvSpPr>
-          <p:cNvPr id="24" name="Connector line-1792338542704-293480118"/>
-          <p:cNvSpPr/>
-          <p:nvPr/>
-        </p:nvSpPr>
-        <p:spPr>
-          <a:xfrm>
-            <a:off x="12687300" y="7562850"/>
+          <p:cNvPr id="25" name="Shape 23"/>
+          <p:cNvSpPr/>
+          <p:nvPr/>
+        </p:nvSpPr>
+        <p:spPr>
+          <a:xfrm>
+            <a:off x="13411200" y="1600200"/>
+            <a:ext cx="3657600" cy="1219200"/>
+          </a:xfrm>
+          <a:prstGeom prst="roundRect">
+            <a:avLst>
+              <a:gd name="adj" fmla="val 18750"/>
+            </a:avLst>
+          </a:prstGeom>
+          <a:solidFill>
+            <a:srgbClr val="F3EEE3"/>
+          </a:solidFill>
+          <a:ln w="19050">
+            <a:solidFill>
+              <a:srgbClr val="DDD5C1"/>
+            </a:solidFill>
+            <a:prstDash val="solid"/>
+          </a:ln>
+        </p:spPr>
+      </p:sp>
+      <p:sp>
+        <p:nvSpPr>
+          <p:cNvPr id="26" name="Connector line-1792338542704-293480118"/>
+          <p:cNvSpPr/>
+          <p:nvPr/>
+        </p:nvSpPr>
+        <p:spPr>
+          <a:xfrm>
+            <a:off x="12687300" y="7696200"/>
             <a:ext cx="628650" cy="0"/>
           </a:xfrm>
           <a:prstGeom prst="line">
@@ -13752,18 +13793,57 @@
       </p:sp>
       <p:sp>
         <p:nvSpPr>
-          <p:cNvPr id="25" name="Shape 23"/>
-          <p:cNvSpPr/>
-          <p:nvPr/>
-        </p:nvSpPr>
-        <p:spPr>
-          <a:xfrm>
-            <a:off x="13411200" y="6800850"/>
-            <a:ext cx="3657600" cy="1524000"/>
+          <p:cNvPr id="27" name="Text 25"/>
+          <p:cNvSpPr/>
+          <p:nvPr/>
+        </p:nvSpPr>
+        <p:spPr>
+          <a:xfrm>
+            <a:off x="13639800" y="1695450"/>
+            <a:ext cx="3238500" cy="495300"/>
+          </a:xfrm>
+          <a:prstGeom prst="rect">
+            <a:avLst/>
+          </a:prstGeom>
+          <a:noFill/>
+          <a:ln/>
+        </p:spPr>
+        <p:txBody>
+          <a:bodyPr wrap="square" lIns="0" tIns="0" rIns="0" bIns="0" rtlCol="0" anchor="t"/>
+          <a:lstStyle/>
+          <a:p>
+            <a:pPr algn="l" indent="0" marL="0">
+              <a:buNone/>
+            </a:pPr>
+            <a:r>
+              <a:rPr lang="en-US" sz="2850" dirty="0" kern="0">
+                <a:solidFill>
+                  <a:srgbClr val="14161C"/>
+                </a:solidFill>
+                <a:latin typeface="Bricolage Grotesque ExtraBold" pitchFamily="34" charset="0"/>
+                <a:ea typeface="Bricolage Grotesque ExtraBold" pitchFamily="34" charset="-122"/>
+                <a:cs typeface="Bricolage Grotesque ExtraBold" pitchFamily="34" charset="-120"/>
+              </a:rPr>
+              <a:t>List</a:t>
+            </a:r>
+            <a:endParaRPr lang="en-US" sz="2850" dirty="0"/>
+          </a:p>
+        </p:txBody>
+      </p:sp>
+      <p:sp>
+        <p:nvSpPr>
+          <p:cNvPr id="28" name="Shape 26"/>
+          <p:cNvSpPr/>
+          <p:nvPr/>
+        </p:nvSpPr>
+        <p:spPr>
+          <a:xfrm>
+            <a:off x="13411200" y="7086600"/>
+            <a:ext cx="3657600" cy="1219200"/>
           </a:xfrm>
           <a:prstGeom prst="roundRect">
             <a:avLst>
-              <a:gd name="adj" fmla="val 15000"/>
+              <a:gd name="adj" fmla="val 18750"/>
             </a:avLst>
           </a:prstGeom>
           <a:solidFill>
@@ -13779,52 +13859,13 @@
       </p:sp>
       <p:sp>
         <p:nvSpPr>
-          <p:cNvPr id="26" name="Text 24"/>
-          <p:cNvSpPr/>
-          <p:nvPr/>
-        </p:nvSpPr>
-        <p:spPr>
-          <a:xfrm>
-            <a:off x="13639800" y="7010400"/>
-            <a:ext cx="3238500" cy="495300"/>
-          </a:xfrm>
-          <a:prstGeom prst="rect">
-            <a:avLst/>
-          </a:prstGeom>
-          <a:noFill/>
-          <a:ln/>
-        </p:spPr>
-        <p:txBody>
-          <a:bodyPr wrap="square" lIns="0" tIns="0" rIns="0" bIns="0" rtlCol="0" anchor="t"/>
-          <a:lstStyle/>
-          <a:p>
-            <a:pPr algn="l" indent="0" marL="0">
-              <a:buNone/>
-            </a:pPr>
-            <a:r>
-              <a:rPr lang="en-US" sz="2850" dirty="0" spc="1" kern="0">
-                <a:solidFill>
-                  <a:srgbClr val="14161C"/>
-                </a:solidFill>
-                <a:latin typeface="Bricolage Grotesque ExtraBold" pitchFamily="34" charset="0"/>
-                <a:ea typeface="Bricolage Grotesque ExtraBold" pitchFamily="34" charset="-122"/>
-                <a:cs typeface="Bricolage Grotesque ExtraBold" pitchFamily="34" charset="-120"/>
-              </a:rPr>
-              <a:t>HashSet</a:t>
-            </a:r>
-            <a:endParaRPr lang="en-US" sz="2850" dirty="0"/>
-          </a:p>
-        </p:txBody>
-      </p:sp>
-      <p:sp>
-        <p:nvSpPr>
-          <p:cNvPr id="27" name="Text 25"/>
-          <p:cNvSpPr/>
-          <p:nvPr/>
-        </p:nvSpPr>
-        <p:spPr>
-          <a:xfrm>
-            <a:off x="13639800" y="7562850"/>
+          <p:cNvPr id="29" name="Text 27"/>
+          <p:cNvSpPr/>
+          <p:nvPr/>
+        </p:nvSpPr>
+        <p:spPr>
+          <a:xfrm>
+            <a:off x="13639800" y="2190750"/>
             <a:ext cx="3238500" cy="685800"/>
           </a:xfrm>
           <a:prstGeom prst="rect">
@@ -13844,6 +13885,153 @@
               <a:buNone/>
             </a:pPr>
             <a:r>
+              <a:rPr lang="en-US" sz="1800" dirty="0" spc="-10" kern="0">
+                <a:solidFill>
+                  <a:srgbClr val="14161C"/>
+                </a:solidFill>
+                <a:latin typeface="Be Vietnam Pro" pitchFamily="34" charset="0"/>
+                <a:ea typeface="Be Vietnam Pro" pitchFamily="34" charset="-122"/>
+                <a:cs typeface="Be Vietnam Pro" pitchFamily="34" charset="-120"/>
+              </a:rPr>
+              <a:t>dãy</a:t>
+            </a:r>
+            <a:r>
+              <a:rPr lang="en-US" sz="1800" dirty="0" spc="2" kern="0">
+                <a:solidFill>
+                  <a:srgbClr val="14161C"/>
+                </a:solidFill>
+                <a:latin typeface="Be Vietnam Pro" pitchFamily="34" charset="0"/>
+                <a:ea typeface="Be Vietnam Pro" pitchFamily="34" charset="-122"/>
+                <a:cs typeface="Be Vietnam Pro" pitchFamily="34" charset="-120"/>
+              </a:rPr>
+              <a:t> có</a:t>
+            </a:r>
+            <a:r>
+              <a:rPr lang="en-US" sz="1800" dirty="0" spc="-1" kern="0">
+                <a:solidFill>
+                  <a:srgbClr val="14161C"/>
+                </a:solidFill>
+                <a:latin typeface="Be Vietnam Pro" pitchFamily="34" charset="0"/>
+                <a:ea typeface="Be Vietnam Pro" pitchFamily="34" charset="-122"/>
+                <a:cs typeface="Be Vietnam Pro" pitchFamily="34" charset="-120"/>
+              </a:rPr>
+              <a:t> thứ tự, truy</a:t>
+            </a:r>
+            <a:r>
+              <a:rPr lang="en-US" sz="1800" dirty="0" spc="1" kern="0">
+                <a:solidFill>
+                  <a:srgbClr val="14161C"/>
+                </a:solidFill>
+                <a:latin typeface="Be Vietnam Pro" pitchFamily="34" charset="0"/>
+                <a:ea typeface="Be Vietnam Pro" pitchFamily="34" charset="-122"/>
+                <a:cs typeface="Be Vietnam Pro" pitchFamily="34" charset="-120"/>
+              </a:rPr>
+              <a:t> cập</a:t>
+            </a:r>
+            <a:r>
+              <a:rPr lang="en-US" sz="1800" dirty="0" spc="-1" kern="0">
+                <a:solidFill>
+                  <a:srgbClr val="14161C"/>
+                </a:solidFill>
+                <a:latin typeface="Be Vietnam Pro" pitchFamily="34" charset="0"/>
+                <a:ea typeface="Be Vietnam Pro" pitchFamily="34" charset="-122"/>
+                <a:cs typeface="Be Vietnam Pro" pitchFamily="34" charset="-120"/>
+              </a:rPr>
+              <a:t> theo</a:t>
+            </a:r>
+            <a:r>
+              <a:rPr lang="en-US" sz="1800" dirty="0" spc="0" kern="0">
+                <a:solidFill>
+                  <a:srgbClr val="14161C"/>
+                </a:solidFill>
+                <a:latin typeface="Be Vietnam Pro" pitchFamily="34" charset="0"/>
+                <a:ea typeface="Be Vietnam Pro" pitchFamily="34" charset="-122"/>
+                <a:cs typeface="Be Vietnam Pro" pitchFamily="34" charset="-120"/>
+              </a:rPr>
+              <a:t> chỉ</a:t>
+            </a:r>
+            <a:r>
+              <a:rPr lang="en-US" sz="1800" dirty="0" spc="-5" kern="0">
+                <a:solidFill>
+                  <a:srgbClr val="14161C"/>
+                </a:solidFill>
+                <a:latin typeface="Be Vietnam Pro" pitchFamily="34" charset="0"/>
+                <a:ea typeface="Be Vietnam Pro" pitchFamily="34" charset="-122"/>
+                <a:cs typeface="Be Vietnam Pro" pitchFamily="34" charset="-120"/>
+              </a:rPr>
+              <a:t> số</a:t>
+            </a:r>
+            <a:endParaRPr lang="en-US" sz="1800" dirty="0"/>
+          </a:p>
+        </p:txBody>
+      </p:sp>
+      <p:sp>
+        <p:nvSpPr>
+          <p:cNvPr id="30" name="Text 28"/>
+          <p:cNvSpPr/>
+          <p:nvPr/>
+        </p:nvSpPr>
+        <p:spPr>
+          <a:xfrm>
+            <a:off x="13639800" y="7181850"/>
+            <a:ext cx="3238500" cy="495300"/>
+          </a:xfrm>
+          <a:prstGeom prst="rect">
+            <a:avLst/>
+          </a:prstGeom>
+          <a:noFill/>
+          <a:ln/>
+        </p:spPr>
+        <p:txBody>
+          <a:bodyPr wrap="square" lIns="0" tIns="0" rIns="0" bIns="0" rtlCol="0" anchor="t"/>
+          <a:lstStyle/>
+          <a:p>
+            <a:pPr algn="l" indent="0" marL="0">
+              <a:buNone/>
+            </a:pPr>
+            <a:r>
+              <a:rPr lang="en-US" sz="2850" dirty="0" spc="1" kern="0">
+                <a:solidFill>
+                  <a:srgbClr val="14161C"/>
+                </a:solidFill>
+                <a:latin typeface="Bricolage Grotesque ExtraBold" pitchFamily="34" charset="0"/>
+                <a:ea typeface="Bricolage Grotesque ExtraBold" pitchFamily="34" charset="-122"/>
+                <a:cs typeface="Bricolage Grotesque ExtraBold" pitchFamily="34" charset="-120"/>
+              </a:rPr>
+              <a:t>HashSet</a:t>
+            </a:r>
+            <a:endParaRPr lang="en-US" sz="2850" dirty="0"/>
+          </a:p>
+        </p:txBody>
+      </p:sp>
+      <p:sp>
+        <p:nvSpPr>
+          <p:cNvPr id="31" name="Text 29"/>
+          <p:cNvSpPr/>
+          <p:nvPr/>
+        </p:nvSpPr>
+        <p:spPr>
+          <a:xfrm>
+            <a:off x="13639800" y="7677150"/>
+            <a:ext cx="3238500" cy="685800"/>
+          </a:xfrm>
+          <a:prstGeom prst="rect">
+            <a:avLst/>
+          </a:prstGeom>
+          <a:noFill/>
+          <a:ln/>
+        </p:spPr>
+        <p:txBody>
+          <a:bodyPr wrap="square" lIns="0" tIns="9716" rIns="0" bIns="-9716" rtlCol="0" anchor="t"/>
+          <a:lstStyle/>
+          <a:p>
+            <a:pPr algn="l" indent="0" marL="0">
+              <a:lnSpc>
+                <a:spcPts val="2340"/>
+              </a:lnSpc>
+              <a:buNone/>
+            </a:pPr>
+            <a:r>
               <a:rPr lang="en-US" sz="1800" dirty="0" spc="11" kern="0">
                 <a:solidFill>
                   <a:srgbClr val="14161C"/>
@@ -13904,7 +14092,7 @@
       </p:sp>
       <p:sp>
         <p:nvSpPr>
-          <p:cNvPr id="28" name="Shape 26"/>
+          <p:cNvPr id="32" name="Shape 30"/>
           <p:cNvSpPr/>
           <p:nvPr/>
         </p:nvSpPr>
@@ -13929,7 +14117,7 @@
       </p:sp>
       <p:sp>
         <p:nvSpPr>
-          <p:cNvPr id="29" name="Shape 27"/>
+          <p:cNvPr id="33" name="Shape 31"/>
           <p:cNvSpPr/>
           <p:nvPr/>
         </p:nvSpPr>
@@ -13954,7 +14142,7 @@
       </p:sp>
       <p:sp>
         <p:nvSpPr>
-          <p:cNvPr id="30" name="Shape 28"/>
+          <p:cNvPr id="34" name="Shape 32"/>
           <p:cNvSpPr/>
           <p:nvPr/>
         </p:nvSpPr>
@@ -13979,7 +14167,7 @@
       </p:sp>
       <p:sp>
         <p:nvSpPr>
-          <p:cNvPr id="31" name="Shape 29"/>
+          <p:cNvPr id="35" name="Shape 33"/>
           <p:cNvSpPr/>
           <p:nvPr/>
         </p:nvSpPr>
@@ -14004,7 +14192,7 @@
       </p:sp>
       <p:sp>
         <p:nvSpPr>
-          <p:cNvPr id="32" name="Shape 30"/>
+          <p:cNvPr id="36" name="Shape 34"/>
           <p:cNvSpPr/>
           <p:nvPr/>
         </p:nvSpPr>
@@ -14029,7 +14217,7 @@
       </p:sp>
       <p:sp>
         <p:nvSpPr>
-          <p:cNvPr id="33" name="Shape 31"/>
+          <p:cNvPr id="37" name="Shape 35"/>
           <p:cNvSpPr/>
           <p:nvPr/>
         </p:nvSpPr>
@@ -14054,7 +14242,7 @@
       </p:sp>
       <p:sp>
         <p:nvSpPr>
-          <p:cNvPr id="34" name="Shape 32"/>
+          <p:cNvPr id="38" name="Shape 36"/>
           <p:cNvSpPr/>
           <p:nvPr/>
         </p:nvSpPr>
@@ -14079,7 +14267,7 @@
       </p:sp>
       <p:sp>
         <p:nvSpPr>
-          <p:cNvPr id="35" name="Shape 33"/>
+          <p:cNvPr id="39" name="Shape 37"/>
           <p:cNvSpPr/>
           <p:nvPr/>
         </p:nvSpPr>
@@ -14104,7 +14292,7 @@
       </p:sp>
       <p:sp>
         <p:nvSpPr>
-          <p:cNvPr id="36" name="Shape 34"/>
+          <p:cNvPr id="40" name="Shape 38"/>
           <p:cNvSpPr/>
           <p:nvPr/>
         </p:nvSpPr>
@@ -14129,7 +14317,7 @@
       </p:sp>
       <p:sp>
         <p:nvSpPr>
-          <p:cNvPr id="37" name="Text 35"/>
+          <p:cNvPr id="41" name="Text 39"/>
           <p:cNvSpPr/>
           <p:nvPr/>
         </p:nvSpPr>
@@ -14234,18 +14422,18 @@
       </p:sp>
       <p:sp>
         <p:nvSpPr>
-          <p:cNvPr id="38" name="Text 36"/>
-          <p:cNvSpPr/>
-          <p:nvPr/>
-        </p:nvSpPr>
-        <p:spPr>
-          <a:xfrm>
-            <a:off x="9448800" y="1600200"/>
-            <a:ext cx="3143250" cy="1524000"/>
+          <p:cNvPr id="42" name="Text 40"/>
+          <p:cNvSpPr/>
+          <p:nvPr/>
+        </p:nvSpPr>
+        <p:spPr>
+          <a:xfrm>
+            <a:off x="9448800" y="2971800"/>
+            <a:ext cx="3143250" cy="1219200"/>
           </a:xfrm>
           <a:prstGeom prst="roundRect">
             <a:avLst>
-              <a:gd name="adj" fmla="val 15000"/>
+              <a:gd name="adj" fmla="val 18750"/>
             </a:avLst>
           </a:prstGeom>
           <a:solidFill>
@@ -14305,18 +14493,18 @@
       </p:sp>
       <p:sp>
         <p:nvSpPr>
-          <p:cNvPr id="39" name="Text 37"/>
-          <p:cNvSpPr/>
-          <p:nvPr/>
-        </p:nvSpPr>
-        <p:spPr>
-          <a:xfrm>
-            <a:off x="9448800" y="3333750"/>
-            <a:ext cx="3143250" cy="1524000"/>
+          <p:cNvPr id="43" name="Text 41"/>
+          <p:cNvSpPr/>
+          <p:nvPr/>
+        </p:nvSpPr>
+        <p:spPr>
+          <a:xfrm>
+            <a:off x="9448800" y="4343400"/>
+            <a:ext cx="3143250" cy="1219200"/>
           </a:xfrm>
           <a:prstGeom prst="roundRect">
             <a:avLst>
-              <a:gd name="adj" fmla="val 15000"/>
+              <a:gd name="adj" fmla="val 18750"/>
             </a:avLst>
           </a:prstGeom>
           <a:solidFill>
@@ -14376,18 +14564,18 @@
       </p:sp>
       <p:sp>
         <p:nvSpPr>
-          <p:cNvPr id="40" name="Text 38"/>
-          <p:cNvSpPr/>
-          <p:nvPr/>
-        </p:nvSpPr>
-        <p:spPr>
-          <a:xfrm>
-            <a:off x="9448800" y="5067300"/>
-            <a:ext cx="3143250" cy="1524000"/>
+          <p:cNvPr id="44" name="Text 42"/>
+          <p:cNvSpPr/>
+          <p:nvPr/>
+        </p:nvSpPr>
+        <p:spPr>
+          <a:xfrm>
+            <a:off x="9448800" y="5715000"/>
+            <a:ext cx="3143250" cy="1219200"/>
           </a:xfrm>
           <a:prstGeom prst="roundRect">
             <a:avLst>
-              <a:gd name="adj" fmla="val 15000"/>
+              <a:gd name="adj" fmla="val 18750"/>
             </a:avLst>
           </a:prstGeom>
           <a:solidFill>
@@ -14436,18 +14624,18 @@
       </p:sp>
       <p:sp>
         <p:nvSpPr>
-          <p:cNvPr id="41" name="Text 39"/>
-          <p:cNvSpPr/>
-          <p:nvPr/>
-        </p:nvSpPr>
-        <p:spPr>
-          <a:xfrm>
-            <a:off x="9448800" y="6800850"/>
-            <a:ext cx="3143250" cy="1524000"/>
+          <p:cNvPr id="45" name="Text 43"/>
+          <p:cNvSpPr/>
+          <p:nvPr/>
+        </p:nvSpPr>
+        <p:spPr>
+          <a:xfrm>
+            <a:off x="9448800" y="7086600"/>
+            <a:ext cx="3143250" cy="1219200"/>
           </a:xfrm>
           <a:prstGeom prst="roundRect">
             <a:avLst>
-              <a:gd name="adj" fmla="val 15000"/>
+              <a:gd name="adj" fmla="val 18750"/>
             </a:avLst>
           </a:prstGeom>
           <a:solidFill>
@@ -14518,7 +14706,78 @@
       </p:sp>
       <p:sp>
         <p:nvSpPr>
-          <p:cNvPr id="42" name="Shape 40"/>
+          <p:cNvPr id="46" name="Text 44"/>
+          <p:cNvSpPr/>
+          <p:nvPr/>
+        </p:nvSpPr>
+        <p:spPr>
+          <a:xfrm>
+            <a:off x="9448800" y="1600200"/>
+            <a:ext cx="3143250" cy="1219200"/>
+          </a:xfrm>
+          <a:prstGeom prst="roundRect">
+            <a:avLst>
+              <a:gd name="adj" fmla="val 18750"/>
+            </a:avLst>
+          </a:prstGeom>
+          <a:solidFill>
+            <a:srgbClr val="1F3FD1"/>
+          </a:solidFill>
+          <a:ln/>
+        </p:spPr>
+        <p:txBody>
+          <a:bodyPr wrap="square" lIns="0" tIns="0" rIns="0" bIns="0" rtlCol="0" anchor="ctr"/>
+          <a:lstStyle/>
+          <a:p>
+            <a:pPr algn="ctr" indent="0" marL="0">
+              <a:buNone/>
+            </a:pPr>
+            <a:r>
+              <a:rPr lang="en-US" sz="2400" b="1" dirty="0" spc="2" kern="0">
+                <a:solidFill>
+                  <a:srgbClr val="F3EEE3"/>
+                </a:solidFill>
+                <a:latin typeface="Be Vietnam Pro" pitchFamily="34" charset="0"/>
+                <a:ea typeface="Be Vietnam Pro" pitchFamily="34" charset="-122"/>
+                <a:cs typeface="Be Vietnam Pro" pitchFamily="34" charset="-120"/>
+              </a:rPr>
+              <a:t>Danh</a:t>
+            </a:r>
+            <a:r>
+              <a:rPr lang="en-US" sz="2400" b="1" dirty="0" spc="1" kern="0">
+                <a:solidFill>
+                  <a:srgbClr val="F3EEE3"/>
+                </a:solidFill>
+                <a:latin typeface="Be Vietnam Pro" pitchFamily="34" charset="0"/>
+                <a:ea typeface="Be Vietnam Pro" pitchFamily="34" charset="-122"/>
+                <a:cs typeface="Be Vietnam Pro" pitchFamily="34" charset="-120"/>
+              </a:rPr>
+              <a:t> sách</a:t>
+            </a:r>
+            <a:endParaRPr lang="en-US" sz="2400" dirty="0"/>
+          </a:p>
+          <a:p>
+            <a:pPr algn="ctr" indent="0" marL="0">
+              <a:buNone/>
+            </a:pPr>
+            <a:r>
+              <a:rPr lang="en-US" sz="2400" b="1" dirty="0" spc="-3" kern="0">
+                <a:solidFill>
+                  <a:srgbClr val="F3EEE3"/>
+                </a:solidFill>
+                <a:latin typeface="Be Vietnam Pro" pitchFamily="34" charset="0"/>
+                <a:ea typeface="Be Vietnam Pro" pitchFamily="34" charset="-122"/>
+                <a:cs typeface="Be Vietnam Pro" pitchFamily="34" charset="-120"/>
+              </a:rPr>
+              <a:t>(List)</a:t>
+            </a:r>
+            <a:endParaRPr lang="en-US" sz="2400" dirty="0"/>
+          </a:p>
+        </p:txBody>
+      </p:sp>
+      <p:sp>
+        <p:nvSpPr>
+          <p:cNvPr id="47" name="Shape 45"/>
           <p:cNvSpPr/>
           <p:nvPr/>
         </p:nvSpPr>
@@ -14542,7 +14801,7 @@
       </p:sp>
       <p:pic>
         <p:nvPicPr>
-          <p:cNvPr id="43" name="Moda image moda-export-watermark-5854dc3e-1ed9-4591-9ee1-7f0926b50366" descr="">    </p:cNvPr>
+          <p:cNvPr id="48" name="Moda image moda-export-watermark-5854dc3e-1ed9-4591-9ee1-7f0926b50366" descr="">    </p:cNvPr>
           <p:cNvPicPr>
             <a:picLocks noChangeAspect="1"/>
           </p:cNvPicPr>

</xml_diff>